<commit_message>
feat: updated the code of the nn and the latex
</commit_message>
<xml_diff>
--- a/Presentation/presentation.pptx
+++ b/Presentation/presentation.pptx
@@ -708,7 +708,7 @@
           <a:lstStyle/>
           <a:p>
             <a:r>
-              <a:t>Country-grouped validation holds out entire countries, giving the most conservative tuning scores here. Source: original random-forest tuning figure.</a:t>
+              <a:t>Country-grouped validation holds out entire countries, giving the lowest best validation score in this comparison. Source: original random-forest tuning figure.</a:t>
             </a:r>
           </a:p>
         </p:txBody>
@@ -734,6 +734,76 @@
 </file>
 
 <file path=ppt/notesSlides/notesSlide2.xml><?xml version="1.0" encoding="utf-8"?>
+<p:notes xmlns:a="http://schemas.openxmlformats.org/drawingml/2006/main" xmlns:p="http://schemas.openxmlformats.org/presentationml/2006/main" xmlns:r="http://schemas.openxmlformats.org/officeDocument/2006/relationships">
+  <p:cSld>
+    <p:spTree>
+      <p:nvGrpSpPr>
+        <p:cNvPr id="1" name=""/>
+        <p:cNvGrpSpPr/>
+        <p:nvPr/>
+      </p:nvGrpSpPr>
+      <p:grpSpPr>
+        <a:xfrm>
+          <a:off x="0" y="0"/>
+          <a:ext cx="0" cy="0"/>
+          <a:chOff x="0" y="0"/>
+          <a:chExt cx="0" cy="0"/>
+        </a:xfrm>
+      </p:grpSpPr>
+      <p:sp>
+        <p:nvSpPr>
+          <p:cNvPr id="2" name="Slide Image Placeholder 1"/>
+          <p:cNvSpPr>
+            <a:spLocks noGrp="1"/>
+          </p:cNvSpPr>
+          <p:nvPr>
+            <p:ph type="sldImg" idx="2"/>
+          </p:nvPr>
+        </p:nvSpPr>
+        <p:spPr/>
+      </p:sp>
+      <p:sp>
+        <p:nvSpPr>
+          <p:cNvPr id="3" name="Notes Placeholder 2"/>
+          <p:cNvSpPr>
+            <a:spLocks noGrp="1"/>
+          </p:cNvSpPr>
+          <p:nvPr>
+            <p:ph type="body" idx="3" sz="quarter"/>
+          </p:nvPr>
+        </p:nvSpPr>
+        <p:spPr/>
+        <p:txBody>
+          <a:bodyPr/>
+          <a:lstStyle/>
+          <a:p>
+            <a:r>
+              <a:t>0.620 is mean-fold tuning balanced accuracy; 0.630 is pooled development OOF balanced accuracy at threshold 0.51. The latter is not an independent final assessment because development results informed model and threshold selection.</a:t>
+            </a:r>
+          </a:p>
+        </p:txBody>
+      </p:sp>
+      <p:sp>
+        <p:nvSpPr>
+          <p:cNvPr id="4" name="Slide Number Placeholder 3"/>
+          <p:cNvSpPr>
+            <a:spLocks noGrp="1"/>
+          </p:cNvSpPr>
+          <p:nvPr>
+            <p:ph type="sldNum" idx="5" sz="quarter"/>
+          </p:nvPr>
+        </p:nvSpPr>
+        <p:spPr/>
+      </p:sp>
+    </p:spTree>
+  </p:cSld>
+  <p:clrMapOvr>
+    <a:masterClrMapping/>
+  </p:clrMapOvr>
+</p:notes>
+</file>
+
+<file path=ppt/notesSlides/notesSlide3.xml><?xml version="1.0" encoding="utf-8"?>
 <p:notes xmlns:a="http://schemas.openxmlformats.org/drawingml/2006/main" xmlns:p="http://schemas.openxmlformats.org/presentationml/2006/main" xmlns:r="http://schemas.openxmlformats.org/officeDocument/2006/relationships">
   <p:cSld>
     <p:spTree>
@@ -4940,14 +5010,14 @@
       </p:pic>
       <p:sp>
         <p:nvSpPr>
-          <p:cNvPr id="8" name="Permutation importance: mean decrease in accuracy after shuffling each predictor."/>
-          <p:cNvSpPr txBox="1"/>
-          <p:nvPr/>
-        </p:nvSpPr>
-        <p:spPr>
-          <a:xfrm>
-            <a:off x="548640" y="6199632"/>
-            <a:ext cx="6629400" cy="210312"/>
+          <p:cNvPr id="8" name="Permutation importance: mean decrease in ordinary out-of-bag (OOB) accuracy, not balanced "/>
+          <p:cNvSpPr txBox="1"/>
+          <p:nvPr/>
+        </p:nvSpPr>
+        <p:spPr>
+          <a:xfrm>
+            <a:off x="548640" y="6108192"/>
+            <a:ext cx="6629400" cy="365760"/>
           </a:xfrm>
           <a:prstGeom prst="rect">
             <a:avLst/>
@@ -4978,7 +5048,7 @@
               </a:defRPr>
             </a:pPr>
             <a:r>
-              <a:t>Permutation importance: mean decrease in accuracy after shuffling each predictor.</a:t>
+              <a:t>Permutation importance: mean decrease in ordinary out-of-bag (OOB) accuracy, not balanced accuracy, after shuffling each predictor.</a:t>
             </a:r>
           </a:p>
         </p:txBody>
@@ -5254,7 +5324,7 @@
       </p:sp>
       <p:sp>
         <p:nvSpPr>
-          <p:cNvPr id="15" name="Predictive importance is not a causal effect."/>
+          <p:cNvPr id="15" name="Importance establishes neither direction nor causality."/>
           <p:cNvSpPr txBox="1"/>
           <p:nvPr/>
         </p:nvSpPr>
@@ -5292,7 +5362,7 @@
               </a:defRPr>
             </a:pPr>
             <a:r>
-              <a:t>Predictive importance is not a causal effect.</a:t>
+              <a:t>Importance establishes neither direction nor causality.</a:t>
             </a:r>
           </a:p>
         </p:txBody>
@@ -16583,14 +16653,14 @@
       </p:pic>
       <p:sp>
         <p:nvSpPr>
-          <p:cNvPr id="9" name="Flat grid. Curves cross; scores stay within roughly five points. No setting dominates."/>
+          <p:cNvPr id="9" name="Flat grid. Curves cross; scores stay within roughly four to seven percentage points. No se"/>
           <p:cNvSpPr txBox="1"/>
           <p:nvPr/>
         </p:nvSpPr>
         <p:spPr>
           <a:xfrm>
             <a:off x="548640" y="5852160"/>
-            <a:ext cx="5394960" cy="594360"/>
+            <a:ext cx="5394960" cy="658368"/>
           </a:xfrm>
           <a:prstGeom prst="rect">
             <a:avLst/>
@@ -16621,7 +16691,7 @@
               </a:defRPr>
             </a:pPr>
             <a:r>
-              <a:t>Flat grid. Curves cross; scores stay within roughly five points. No setting dominates.</a:t>
+              <a:t>Flat grid. Curves cross; scores stay within roughly four to seven percentage points. No setting dominates.</a:t>
             </a:r>
           </a:p>
         </p:txBody>
@@ -17749,14 +17819,14 @@
       </p:sp>
       <p:sp>
         <p:nvSpPr>
-          <p:cNvPr id="15" name="0.51–0.64"/>
+          <p:cNvPr id="15" name="Threshold = 0.51"/>
           <p:cNvSpPr txBox="1"/>
           <p:nvPr/>
         </p:nvSpPr>
         <p:spPr>
           <a:xfrm>
             <a:off x="7360920" y="1682496"/>
-            <a:ext cx="4279392" cy="685800"/>
+            <a:ext cx="4279392" cy="457200"/>
           </a:xfrm>
           <a:prstGeom prst="rect">
             <a:avLst/>
@@ -17779,7 +17849,7 @@
               <a:spcAft>
                 <a:spcPts val="0"/>
               </a:spcAft>
-              <a:defRPr sz="3600" b="1">
+              <a:defRPr sz="2600" b="1">
                 <a:solidFill>
                   <a:srgbClr val="00843D"/>
                 </a:solidFill>
@@ -17787,21 +17857,21 @@
               </a:defRPr>
             </a:pPr>
             <a:r>
-              <a:t>0.51–0.64</a:t>
-            </a:r>
-          </a:p>
-        </p:txBody>
-      </p:sp>
-      <p:sp>
-        <p:nvSpPr>
-          <p:cNvPr id="16" name="Balanced accuracy"/>
-          <p:cNvSpPr txBox="1"/>
-          <p:nvPr/>
-        </p:nvSpPr>
-        <p:spPr>
-          <a:xfrm>
-            <a:off x="7360920" y="2404872"/>
-            <a:ext cx="4279392" cy="283464"/>
+              <a:t>Threshold = 0.51</a:t>
+            </a:r>
+          </a:p>
+        </p:txBody>
+      </p:sp>
+      <p:sp>
+        <p:nvSpPr>
+          <p:cNvPr id="16" name="Selected using development out-of-fold predictions."/>
+          <p:cNvSpPr txBox="1"/>
+          <p:nvPr/>
+        </p:nvSpPr>
+        <p:spPr>
+          <a:xfrm>
+            <a:off x="7360920" y="2267712"/>
+            <a:ext cx="4279392" cy="822960"/>
           </a:xfrm>
           <a:prstGeom prst="rect">
             <a:avLst/>
@@ -17824,7 +17894,7 @@
               <a:spcAft>
                 <a:spcPts val="0"/>
               </a:spcAft>
-              <a:defRPr sz="1700" b="1">
+              <a:defRPr sz="1700" b="0">
                 <a:solidFill>
                   <a:srgbClr val="17352D"/>
                 </a:solidFill>
@@ -17832,21 +17902,21 @@
               </a:defRPr>
             </a:pPr>
             <a:r>
-              <a:t>Balanced accuracy</a:t>
-            </a:r>
-          </a:p>
-        </p:txBody>
-      </p:sp>
-      <p:sp>
-        <p:nvSpPr>
-          <p:cNvPr id="17" name="Across 20 random seeds"/>
-          <p:cNvSpPr txBox="1"/>
-          <p:nvPr/>
-        </p:nvSpPr>
-        <p:spPr>
-          <a:xfrm>
-            <a:off x="7360920" y="2734056"/>
-            <a:ext cx="4279392" cy="384048"/>
+              <a:t>Selected using development out-of-fold predictions.</a:t>
+            </a:r>
+          </a:p>
+        </p:txBody>
+      </p:sp>
+      <p:sp>
+        <p:nvSpPr>
+          <p:cNvPr id="17" name="28 test programmes"/>
+          <p:cNvSpPr txBox="1"/>
+          <p:nvPr/>
+        </p:nvSpPr>
+        <p:spPr>
+          <a:xfrm>
+            <a:off x="7360920" y="3483864"/>
+            <a:ext cx="4279392" cy="457200"/>
           </a:xfrm>
           <a:prstGeom prst="rect">
             <a:avLst/>
@@ -17869,29 +17939,29 @@
               <a:spcAft>
                 <a:spcPts val="0"/>
               </a:spcAft>
-              <a:defRPr sz="1150" b="0">
-                <a:solidFill>
-                  <a:srgbClr val="60716B"/>
-                </a:solidFill>
-                <a:latin typeface="Arial"/>
-              </a:defRPr>
-            </a:pPr>
-            <a:r>
-              <a:t>Across 20 random seeds</a:t>
-            </a:r>
-          </a:p>
-        </p:txBody>
-      </p:sp>
-      <p:sp>
-        <p:nvSpPr>
-          <p:cNvPr id="18" name="0.38–0.75"/>
-          <p:cNvSpPr txBox="1"/>
-          <p:nvPr/>
-        </p:nvSpPr>
-        <p:spPr>
-          <a:xfrm>
-            <a:off x="7360920" y="3483864"/>
-            <a:ext cx="4279392" cy="685800"/>
+              <a:defRPr sz="2600" b="1">
+                <a:solidFill>
+                  <a:srgbClr val="00843D"/>
+                </a:solidFill>
+                <a:latin typeface="Arial"/>
+              </a:defRPr>
+            </a:pPr>
+            <a:r>
+              <a:t>28 test programmes</a:t>
+            </a:r>
+          </a:p>
+        </p:txBody>
+      </p:sp>
+      <p:sp>
+        <p:nvSpPr>
+          <p:cNvPr id="18" name="One additional correct prediction changes balanced accuracy by approximately 0.03–0.05."/>
+          <p:cNvSpPr txBox="1"/>
+          <p:nvPr/>
+        </p:nvSpPr>
+        <p:spPr>
+          <a:xfrm>
+            <a:off x="7360920" y="4069080"/>
+            <a:ext cx="4279392" cy="932688"/>
           </a:xfrm>
           <a:prstGeom prst="rect">
             <a:avLst/>
@@ -17914,52 +17984,7 @@
               <a:spcAft>
                 <a:spcPts val="0"/>
               </a:spcAft>
-              <a:defRPr sz="3600" b="1">
-                <a:solidFill>
-                  <a:srgbClr val="00843D"/>
-                </a:solidFill>
-                <a:latin typeface="Arial"/>
-              </a:defRPr>
-            </a:pPr>
-            <a:r>
-              <a:t>0.38–0.75</a:t>
-            </a:r>
-          </a:p>
-        </p:txBody>
-      </p:sp>
-      <p:sp>
-        <p:nvSpPr>
-          <p:cNvPr id="19" name="Bootstrap interval"/>
-          <p:cNvSpPr txBox="1"/>
-          <p:nvPr/>
-        </p:nvSpPr>
-        <p:spPr>
-          <a:xfrm>
-            <a:off x="7360920" y="4206240"/>
-            <a:ext cx="4279392" cy="283464"/>
-          </a:xfrm>
-          <a:prstGeom prst="rect">
-            <a:avLst/>
-          </a:prstGeom>
-          <a:noFill/>
-        </p:spPr>
-        <p:txBody>
-          <a:bodyPr wrap="square" lIns="0" rIns="0" tIns="0" bIns="0" anchor="t">
-            <a:noAutofit/>
-          </a:bodyPr>
-          <a:lstStyle/>
-          <a:p>
-            <a:pPr algn="l">
-              <a:lnSpc>
-                <a:spcPct val="110000"/>
-              </a:lnSpc>
-              <a:spcBef>
-                <a:spcPts val="0"/>
-              </a:spcBef>
-              <a:spcAft>
-                <a:spcPts val="0"/>
-              </a:spcAft>
-              <a:defRPr sz="1700" b="1">
+              <a:defRPr sz="1700" b="0">
                 <a:solidFill>
                   <a:srgbClr val="17352D"/>
                 </a:solidFill>
@@ -17967,59 +17992,14 @@
               </a:defRPr>
             </a:pPr>
             <a:r>
-              <a:t>Bootstrap interval</a:t>
-            </a:r>
-          </a:p>
-        </p:txBody>
-      </p:sp>
-      <p:sp>
-        <p:nvSpPr>
-          <p:cNvPr id="20" name="Reported 95% interval; includes 0.50"/>
-          <p:cNvSpPr txBox="1"/>
-          <p:nvPr/>
-        </p:nvSpPr>
-        <p:spPr>
-          <a:xfrm>
-            <a:off x="7360920" y="4535424"/>
-            <a:ext cx="4279392" cy="384048"/>
-          </a:xfrm>
-          <a:prstGeom prst="rect">
-            <a:avLst/>
-          </a:prstGeom>
-          <a:noFill/>
-        </p:spPr>
-        <p:txBody>
-          <a:bodyPr wrap="square" lIns="0" rIns="0" tIns="0" bIns="0" anchor="t">
-            <a:noAutofit/>
-          </a:bodyPr>
-          <a:lstStyle/>
-          <a:p>
-            <a:pPr algn="l">
-              <a:lnSpc>
-                <a:spcPct val="110000"/>
-              </a:lnSpc>
-              <a:spcBef>
-                <a:spcPts val="0"/>
-              </a:spcBef>
-              <a:spcAft>
-                <a:spcPts val="0"/>
-              </a:spcAft>
-              <a:defRPr sz="1150" b="0">
-                <a:solidFill>
-                  <a:srgbClr val="60716B"/>
-                </a:solidFill>
-                <a:latin typeface="Arial"/>
-              </a:defRPr>
-            </a:pPr>
-            <a:r>
-              <a:t>Reported 95% interval; includes 0.50</a:t>
-            </a:r>
-          </a:p>
-        </p:txBody>
-      </p:sp>
-      <p:sp>
-        <p:nvSpPr>
-          <p:cNvPr id="21" name="With only 28 test observations, the result is sensitive to random variation."/>
+              <a:t>One additional correct prediction changes balanced accuracy by approximately 0.03–0.05.</a:t>
+            </a:r>
+          </a:p>
+        </p:txBody>
+      </p:sp>
+      <p:sp>
+        <p:nvSpPr>
+          <p:cNvPr id="19" name="With only 28 test observations, the result is sensitive to random variation."/>
           <p:cNvSpPr txBox="1"/>
           <p:nvPr/>
         </p:nvSpPr>
@@ -18064,7 +18044,7 @@
       </p:sp>
       <p:sp>
         <p:nvSpPr>
-          <p:cNvPr id="22" name="Rectangle 21"/>
+          <p:cNvPr id="20" name="Rectangle 19"/>
           <p:cNvSpPr/>
           <p:nvPr/>
         </p:nvSpPr>
@@ -18108,7 +18088,7 @@
       </p:sp>
       <p:sp>
         <p:nvSpPr>
-          <p:cNvPr id="23" name="The development signal does not translate into a reliable test-set edge over chance."/>
+          <p:cNvPr id="21" name="The development signal does not translate into a reliable test-set edge over chance."/>
           <p:cNvSpPr txBox="1"/>
           <p:nvPr/>
         </p:nvSpPr>

</xml_diff>